<commit_message>
docs: brand pitch deck, rewrite README, add architecture diagrams
- Apply Plum & Gold brand to pitch-deck-updated (backgrounds, plum/gold
  titles, gold accent rules, dark bookends); fix invisible text; add a
  centered YouTube play icon on the demo slide; export matching PDF.
- README: rewrite intro into two detailed paragraphs; fix mermaid parse
  errors (quote @-labels, drop semicolon/`\n` in sequence notes); remove
  the broken Architecture diagram, SPEC/docs references, placeholders,
  Additional docs, and What's-not-yet-wired/Honesty notes; set Team to
  Artisam Labs and License to MIT.
- Add architecture diagram assets, draft-deck PDF, and homepage logo.

Co-Authored-By: Claude Opus 4.8 <noreply@anthropic.com>
</commit_message>
<xml_diff>
--- a/docs/pitch-deck-draft-Trexure.pptx
+++ b/docs/pitch-deck-draft-Trexure.pptx
@@ -4274,7 +4274,7 @@
         <p:spPr>
           <a:xfrm>
             <a:off x="640080" y="548640"/>
-            <a:ext cx="7863840" cy="914400"/>
+            <a:ext cx="7863840" cy="1280160"/>
           </a:xfrm>
           <a:prstGeom prst="rect">
             <a:avLst/>
@@ -4282,13 +4282,13 @@
           <a:noFill/>
         </p:spPr>
         <p:txBody>
-          <a:bodyPr wrap="none">
+          <a:bodyPr wrap="square">
             <a:spAutoFit/>
           </a:bodyPr>
           <a:lstStyle/>
           <a:p>
             <a:pPr>
-              <a:defRPr sz="3600" b="1"/>
+              <a:defRPr sz="3200" b="1"/>
             </a:pPr>
             <a:r>
               <a:t>Public by default. Useless to finance.</a:t>

</xml_diff>